<commit_message>
Integrate Moral Machine narrative into slides 26–28 and add visual preview
- Slide 26: Updated subtitle and Core Problem text to include the concluding framing ("To conclude: looking toward the future…" and "This is the Moral Machine paradox")
- Slide 27: Replaced placeholder subtitle with full narrative — the intersection dilemma with elderly, child, and parent+infant; added bridge to autonomous systems frontier
- Slide 28: Updated Strategic Frontier (IV) text to include the concluding statement about extending RECIR from real-estate risk to autonomous systems decision-making
- Added posts/preview_moral_machine.html — visual HTML preview of slides 26–28 in Prestige Executive colour scheme

https://claude.ai/code/session_01GyeBaidVdHToPpLeBxWT3s
</commit_message>
<xml_diff>
--- a/RECIR_Defense_v3_FINAL_PROOFED_2.pptx
+++ b/RECIR_Defense_v3_FINAL_PROOFED_2.pptx
@@ -33733,7 +33733,7 @@
                 </a:solidFill>
                 <a:latin typeface="Calibri"/>
               </a:rPr>
-              <a:t>26 / 39</a:t>
+              <a:t>26 / 40</a:t>
             </a:r>
           </a:p>
         </p:txBody>
@@ -33850,7 +33850,7 @@
                 </a:solidFill>
                 <a:latin typeface="Georgia"/>
               </a:rPr>
-              <a:t>How do we translate human morality into executable code? — the Moral Machine paradox.</a:t>
+              <a:t>To conclude: looking toward the future — how do we translate human morality into executable code when unavoidable harm becomes a programmed decision?</a:t>
             </a:r>
           </a:p>
         </p:txBody>
@@ -34018,7 +34018,7 @@
                 </a:solidFill>
                 <a:latin typeface="Calibri"/>
               </a:rPr>
-              <a:t>When unavoidable harm becomes a programmed decision — how does law, economics, and ethics respond?</a:t>
+              <a:t>The core problem: when a programmed decision must choose between lives — how do law, economics, and ethics respond? This is the Moral Machine paradox.</a:t>
             </a:r>
           </a:p>
         </p:txBody>
@@ -35258,7 +35258,7 @@
                 </a:solidFill>
                 <a:latin typeface="Calibri"/>
               </a:rPr>
-              <a:t>27 / 39</a:t>
+              <a:t>27 / 40</a:t>
             </a:r>
           </a:p>
         </p:txBody>
@@ -35375,7 +35375,7 @@
                 </a:solidFill>
                 <a:latin typeface="Georgia"/>
               </a:rPr>
-              <a:t>A single intersection. Three lives. One algorithmic decision.</a:t>
+              <a:t>Imagine a single intersection: an autonomous vehicle faces a dilemma — an elderly person with right of way, a child in the road, a parent with an infant at a crosswalk. Whose life does the algorithm value, and on what legal, economic, and ethical basis?</a:t>
             </a:r>
           </a:p>
         </p:txBody>
@@ -36317,7 +36317,7 @@
                 </a:solidFill>
                 <a:latin typeface="Calibri"/>
               </a:rPr>
-              <a:t>Illustrative scenario  ·  Drawn from the canonical "Moral Machine" experiment (MIT Media Lab) — adapted for legal-economic analysis.</a:t>
+              <a:t>Illustrative scenario · Drawn from the canonical "Moral Machine" experiment (MIT Media Lab) — adapted for Law, Economics &amp; XAI analysis.ic analysis.</a:t>
             </a:r>
           </a:p>
         </p:txBody>
@@ -36471,7 +36471,7 @@
                 </a:solidFill>
                 <a:latin typeface="Calibri"/>
               </a:rPr>
-              <a:t>28 / 39</a:t>
+              <a:t>28 / 40</a:t>
             </a:r>
           </a:p>
         </p:txBody>
@@ -37623,7 +37623,7 @@
                 </a:solidFill>
                 <a:latin typeface="Georgia"/>
               </a:rPr>
-              <a:t>An in-depth investigation into the legal, economic, and technological decision-making frameworks of autonomous systems (vehicles and machinery) — a vital frontier for the future of AI integration.</a:t>
+              <a:t>This illustrates our next strategic frontier: extending the RECIR framework of Law, Economics, and Explainable AI from real-estate risk to the complex decision-making of autonomous systems — where algorithmic choices carry irreversible human consequences.vehicles and machinery) — a vital frontier for the future of AI integration.</a:t>
             </a:r>
           </a:p>
         </p:txBody>

</xml_diff>